<commit_message>
Fix BG/MK presentations: Cyrillic-safe font, shorter text to fit slides
Co-Authored-By: Claude Sonnet 5.5 <noreply@anthropic.com>
</commit_message>
<xml_diff>
--- a/promo/presentation/EntoFARM_presentation_BG.pptx
+++ b/promo/presentation/EntoFARM_presentation_BG.pptx
@@ -3792,7 +3792,7 @@
                 <a:solidFill>
                   <a:srgbClr val="FFFFFF"/>
                 </a:solidFill>
-                <a:latin typeface="Open Sauce"/>
+                <a:latin typeface="Arial"/>
                 <a:ea typeface="Open Sauce"/>
                 <a:cs typeface="Open Sauce"/>
                 <a:sym typeface="Open Sauce"/>
@@ -4793,11 +4793,11 @@
               </a:spcBef>
             </a:pPr>
             <a:r>
-              <a:rPr lang="en-US" b="true" sz="4400">
+              <a:rPr lang="en-US" b="1" sz="4400">
                 <a:solidFill>
                   <a:srgbClr val="32620E"/>
                 </a:solidFill>
-                <a:latin typeface="Poppins Bold"/>
+                <a:latin typeface="Arial"/>
                 <a:ea typeface="Poppins Bold"/>
                 <a:cs typeface="Poppins Bold"/>
                 <a:sym typeface="Poppins Bold"/>
@@ -5875,11 +5875,11 @@
               </a:spcBef>
             </a:pPr>
             <a:r>
-              <a:rPr lang="en-US" b="true" sz="4400">
+              <a:rPr lang="en-US" b="1" sz="4400">
                 <a:solidFill>
                   <a:srgbClr val="32620E"/>
                 </a:solidFill>
-                <a:latin typeface="Poppins Bold"/>
+                <a:latin typeface="Arial"/>
                 <a:ea typeface="Poppins Bold"/>
                 <a:cs typeface="Poppins Bold"/>
                 <a:sym typeface="Poppins Bold"/>
@@ -5920,7 +5920,7 @@
                 <a:solidFill>
                   <a:srgbClr val="FFFFFF"/>
                 </a:solidFill>
-                <a:latin typeface="Canva Sans"/>
+                <a:latin typeface="Arial"/>
                 <a:ea typeface="Canva Sans"/>
                 <a:cs typeface="Canva Sans"/>
                 <a:sym typeface="Canva Sans"/>
@@ -5961,7 +5961,7 @@
                 <a:solidFill>
                   <a:srgbClr val="FFFFFF"/>
                 </a:solidFill>
-                <a:latin typeface="Canva Sans"/>
+                <a:latin typeface="Arial"/>
                 <a:ea typeface="Canva Sans"/>
                 <a:cs typeface="Canva Sans"/>
                 <a:sym typeface="Canva Sans"/>
@@ -6002,7 +6002,7 @@
                 <a:solidFill>
                   <a:srgbClr val="FFFFFF"/>
                 </a:solidFill>
-                <a:latin typeface="Canva Sans"/>
+                <a:latin typeface="Arial"/>
                 <a:ea typeface="Canva Sans"/>
                 <a:cs typeface="Canva Sans"/>
                 <a:sym typeface="Canva Sans"/>
@@ -6043,7 +6043,7 @@
                 <a:solidFill>
                   <a:srgbClr val="FFFFFF"/>
                 </a:solidFill>
-                <a:latin typeface="Canva Sans"/>
+                <a:latin typeface="Arial"/>
                 <a:ea typeface="Canva Sans"/>
                 <a:cs typeface="Canva Sans"/>
                 <a:sym typeface="Canva Sans"/>
@@ -6966,7 +6966,7 @@
                 <a:solidFill>
                   <a:srgbClr val="FFFFFF"/>
                 </a:solidFill>
-                <a:latin typeface="Canva Sans"/>
+                <a:latin typeface="Arial"/>
                 <a:ea typeface="Canva Sans"/>
                 <a:cs typeface="Canva Sans"/>
                 <a:sym typeface="Canva Sans"/>
@@ -7006,11 +7006,11 @@
               </a:spcBef>
             </a:pPr>
             <a:r>
-              <a:rPr lang="en-US" b="true" sz="4400">
+              <a:rPr lang="en-US" b="1" sz="4400">
                 <a:solidFill>
                   <a:srgbClr val="32620E"/>
                 </a:solidFill>
-                <a:latin typeface="Poppins Bold"/>
+                <a:latin typeface="Arial"/>
                 <a:ea typeface="Poppins Bold"/>
                 <a:cs typeface="Poppins Bold"/>
                 <a:sym typeface="Poppins Bold"/>
@@ -7051,7 +7051,7 @@
                 <a:solidFill>
                   <a:srgbClr val="FFFFFF"/>
                 </a:solidFill>
-                <a:latin typeface="Canva Sans"/>
+                <a:latin typeface="Arial"/>
                 <a:ea typeface="Canva Sans"/>
                 <a:cs typeface="Canva Sans"/>
                 <a:sym typeface="Canva Sans"/>
@@ -7092,7 +7092,7 @@
                 <a:solidFill>
                   <a:srgbClr val="FFFFFF"/>
                 </a:solidFill>
-                <a:latin typeface="Canva Sans"/>
+                <a:latin typeface="Arial"/>
                 <a:ea typeface="Canva Sans"/>
                 <a:cs typeface="Canva Sans"/>
                 <a:sym typeface="Canva Sans"/>
@@ -7133,7 +7133,7 @@
                 <a:solidFill>
                   <a:srgbClr val="FFFFFF"/>
                 </a:solidFill>
-                <a:latin typeface="Canva Sans"/>
+                <a:latin typeface="Arial"/>
                 <a:ea typeface="Canva Sans"/>
                 <a:cs typeface="Canva Sans"/>
                 <a:sym typeface="Canva Sans"/>
@@ -8245,11 +8245,11 @@
               </a:spcBef>
             </a:pPr>
             <a:r>
-              <a:rPr lang="en-US" b="true" sz="4400">
+              <a:rPr lang="en-US" b="1" sz="4400">
                 <a:solidFill>
                   <a:srgbClr val="32620E"/>
                 </a:solidFill>
-                <a:latin typeface="Poppins Bold"/>
+                <a:latin typeface="Arial"/>
                 <a:ea typeface="Poppins Bold"/>
                 <a:cs typeface="Poppins Bold"/>
                 <a:sym typeface="Poppins Bold"/>
@@ -8286,11 +8286,11 @@
               </a:lnSpc>
             </a:pPr>
             <a:r>
-              <a:rPr lang="en-US" sz="2500" b="true">
+              <a:rPr lang="en-US" sz="2500" b="1">
                 <a:solidFill>
                   <a:srgbClr val="70574B"/>
                 </a:solidFill>
-                <a:latin typeface="Canva Sans Bold"/>
+                <a:latin typeface="Arial"/>
                 <a:ea typeface="Canva Sans Bold"/>
                 <a:cs typeface="Canva Sans Bold"/>
                 <a:sym typeface="Canva Sans Bold"/>
@@ -8327,11 +8327,11 @@
               </a:lnSpc>
             </a:pPr>
             <a:r>
-              <a:rPr lang="en-US" sz="2500" b="true">
+              <a:rPr lang="en-US" sz="2500" b="1">
                 <a:solidFill>
                   <a:srgbClr val="70574B"/>
                 </a:solidFill>
-                <a:latin typeface="Canva Sans Bold"/>
+                <a:latin typeface="Arial"/>
                 <a:ea typeface="Canva Sans Bold"/>
                 <a:cs typeface="Canva Sans Bold"/>
                 <a:sym typeface="Canva Sans Bold"/>
@@ -8368,11 +8368,11 @@
               </a:lnSpc>
             </a:pPr>
             <a:r>
-              <a:rPr lang="en-US" sz="2500" b="true">
+              <a:rPr lang="en-US" sz="2500" b="1">
                 <a:solidFill>
                   <a:srgbClr val="70574B"/>
                 </a:solidFill>
-                <a:latin typeface="Canva Sans Bold"/>
+                <a:latin typeface="Arial"/>
                 <a:ea typeface="Canva Sans Bold"/>
                 <a:cs typeface="Canva Sans Bold"/>
                 <a:sym typeface="Canva Sans Bold"/>
@@ -8409,11 +8409,11 @@
               </a:lnSpc>
             </a:pPr>
             <a:r>
-              <a:rPr lang="en-US" sz="2500" b="true">
+              <a:rPr lang="en-US" sz="2500" b="1">
                 <a:solidFill>
                   <a:srgbClr val="70574B"/>
                 </a:solidFill>
-                <a:latin typeface="Canva Sans Bold"/>
+                <a:latin typeface="Arial"/>
                 <a:ea typeface="Canva Sans Bold"/>
                 <a:cs typeface="Canva Sans Bold"/>
                 <a:sym typeface="Canva Sans Bold"/>
@@ -8450,11 +8450,11 @@
               </a:lnSpc>
             </a:pPr>
             <a:r>
-              <a:rPr lang="en-US" sz="2500" b="true">
+              <a:rPr lang="en-US" sz="2500" b="1">
                 <a:solidFill>
                   <a:srgbClr val="70574B"/>
                 </a:solidFill>
-                <a:latin typeface="Canva Sans Bold"/>
+                <a:latin typeface="Arial"/>
                 <a:ea typeface="Canva Sans Bold"/>
                 <a:cs typeface="Canva Sans Bold"/>
                 <a:sym typeface="Canva Sans Bold"/>
@@ -9336,11 +9336,11 @@
               </a:spcBef>
             </a:pPr>
             <a:r>
-              <a:rPr lang="en-US" b="true" sz="4400">
+              <a:rPr lang="en-US" b="1" sz="4400">
                 <a:solidFill>
                   <a:srgbClr val="32620E"/>
                 </a:solidFill>
-                <a:latin typeface="Poppins Bold"/>
+                <a:latin typeface="Arial"/>
                 <a:ea typeface="Poppins Bold"/>
                 <a:cs typeface="Poppins Bold"/>
                 <a:sym typeface="Poppins Bold"/>
@@ -9377,11 +9377,11 @@
               </a:lnSpc>
             </a:pPr>
             <a:r>
-              <a:rPr lang="en-US" sz="2499" b="true">
+              <a:rPr lang="en-US" sz="2499" b="1">
                 <a:solidFill>
                   <a:srgbClr val="FFFFFD"/>
                 </a:solidFill>
-                <a:latin typeface="Canva Sans Bold"/>
+                <a:latin typeface="Arial"/>
                 <a:ea typeface="Canva Sans Bold"/>
                 <a:cs typeface="Canva Sans Bold"/>
                 <a:sym typeface="Canva Sans Bold"/>
@@ -9396,11 +9396,11 @@
               </a:lnSpc>
             </a:pPr>
             <a:r>
-              <a:rPr lang="en-US" sz="2499" b="true">
+              <a:rPr lang="en-US" sz="2499" b="1">
                 <a:solidFill>
                   <a:srgbClr val="FFFFFD"/>
                 </a:solidFill>
-                <a:latin typeface="Canva Sans Bold"/>
+                <a:latin typeface="Arial"/>
                 <a:ea typeface="Canva Sans Bold"/>
                 <a:cs typeface="Canva Sans Bold"/>
                 <a:sym typeface="Canva Sans Bold"/>
@@ -9437,11 +9437,11 @@
               </a:lnSpc>
             </a:pPr>
             <a:r>
-              <a:rPr lang="en-US" sz="2499" b="true">
+              <a:rPr lang="en-US" sz="2499" b="1">
                 <a:solidFill>
                   <a:srgbClr val="FFFFFD"/>
                 </a:solidFill>
-                <a:latin typeface="Canva Sans Bold"/>
+                <a:latin typeface="Arial"/>
                 <a:ea typeface="Canva Sans Bold"/>
                 <a:cs typeface="Canva Sans Bold"/>
                 <a:sym typeface="Canva Sans Bold"/>
@@ -9456,16 +9456,16 @@
               </a:lnSpc>
             </a:pPr>
             <a:r>
-              <a:rPr lang="en-US" sz="2499" b="true">
+              <a:rPr lang="en-US" sz="2499" b="1">
                 <a:solidFill>
                   <a:srgbClr val="FFFFFD"/>
                 </a:solidFill>
-                <a:latin typeface="Canva Sans Bold"/>
+                <a:latin typeface="Arial"/>
                 <a:ea typeface="Canva Sans Bold"/>
                 <a:cs typeface="Canva Sans Bold"/>
                 <a:sym typeface="Canva Sans Bold"/>
               </a:rPr>
-              <a:t>Участвайте практически в отглеждането на насекоми и направете документален филм за него.</a:t>
+              <a:t>Участвайте практически в отглеждането на насекоми и заснемете документален филм.</a:t>
             </a:r>
           </a:p>
         </p:txBody>
@@ -9497,11 +9497,11 @@
               </a:lnSpc>
             </a:pPr>
             <a:r>
-              <a:rPr lang="en-US" sz="2499" b="true">
+              <a:rPr lang="en-US" sz="2499" b="1">
                 <a:solidFill>
                   <a:srgbClr val="FFFFFD"/>
                 </a:solidFill>
-                <a:latin typeface="Canva Sans Bold"/>
+                <a:latin typeface="Arial"/>
                 <a:ea typeface="Canva Sans Bold"/>
                 <a:cs typeface="Canva Sans Bold"/>
                 <a:sym typeface="Canva Sans Bold"/>
@@ -9516,11 +9516,11 @@
               </a:lnSpc>
             </a:pPr>
             <a:r>
-              <a:rPr lang="en-US" sz="2499" b="true">
+              <a:rPr lang="en-US" sz="2499" b="1">
                 <a:solidFill>
                   <a:srgbClr val="FFFFFD"/>
                 </a:solidFill>
-                <a:latin typeface="Canva Sans Bold"/>
+                <a:latin typeface="Arial"/>
                 <a:ea typeface="Canva Sans Bold"/>
                 <a:cs typeface="Canva Sans Bold"/>
                 <a:sym typeface="Canva Sans Bold"/>
@@ -9557,11 +9557,11 @@
               </a:lnSpc>
             </a:pPr>
             <a:r>
-              <a:rPr lang="en-US" sz="2499" b="true">
+              <a:rPr lang="en-US" sz="2499" b="1">
                 <a:solidFill>
                   <a:srgbClr val="FFFFFD"/>
                 </a:solidFill>
-                <a:latin typeface="Canva Sans Bold"/>
+                <a:latin typeface="Arial"/>
                 <a:ea typeface="Canva Sans Bold"/>
                 <a:cs typeface="Canva Sans Bold"/>
                 <a:sym typeface="Canva Sans Bold"/>
@@ -9576,16 +9576,16 @@
               </a:lnSpc>
             </a:pPr>
             <a:r>
-              <a:rPr lang="en-US" sz="2499" b="true">
+              <a:rPr lang="en-US" sz="2499" b="1">
                 <a:solidFill>
                   <a:srgbClr val="FFFFFD"/>
                 </a:solidFill>
-                <a:latin typeface="Canva Sans Bold"/>
+                <a:latin typeface="Arial"/>
                 <a:ea typeface="Canva Sans Bold"/>
                 <a:cs typeface="Canva Sans Bold"/>
                 <a:sym typeface="Canva Sans Bold"/>
               </a:rPr>
-              <a:t>Подкрепете проекта и възприемете устойчиви практики.</a:t>
+              <a:t>Подкрепете проекта и устойчивите практики.</a:t>
             </a:r>
           </a:p>
         </p:txBody>
@@ -9757,11 +9757,11 @@
               </a:lnSpc>
             </a:pPr>
             <a:r>
-              <a:rPr lang="en-US" sz="6000">
+              <a:rPr lang="en-US" sz="5200" b="1">
                 <a:solidFill>
                   <a:srgbClr val="FFFFFF"/>
                 </a:solidFill>
-                <a:latin typeface="Oswald"/>
+                <a:latin typeface="Arial"/>
                 <a:ea typeface="Oswald"/>
                 <a:cs typeface="Oswald"/>
                 <a:sym typeface="Oswald"/>
@@ -10076,7 +10076,7 @@
                 <a:solidFill>
                   <a:srgbClr val="FFFFFF"/>
                 </a:solidFill>
-                <a:latin typeface="Canva Sans"/>
+                <a:latin typeface="Arial"/>
                 <a:ea typeface="Canva Sans"/>
                 <a:cs typeface="Canva Sans"/>
                 <a:sym typeface="Canva Sans"/>

</xml_diff>